<commit_message>
Improve the schematic on VTRs
</commit_message>
<xml_diff>
--- a/chapter_05/figures/schematic_verifying_rainfall_thresholds.pptx
+++ b/chapter_05/figures/schematic_verifying_rainfall_thresholds.pptx
@@ -104,7 +104,153 @@
       </a:defRPr>
     </a:lvl9pPr>
   </p:defaultTextStyle>
+  <p:extLst>
+    <p:ext uri="{EFAFB233-063F-42B5-8137-9DF3F51BA10A}">
+      <p15:sldGuideLst xmlns:p15="http://schemas.microsoft.com/office/powerpoint/2012/main"/>
+    </p:ext>
+  </p:extLst>
 </p:presentation>
+</file>
+
+<file path=ppt/revisionInfo.xml><?xml version="1.0" encoding="utf-8"?>
+<p1510:revInfo xmlns:a="http://schemas.openxmlformats.org/drawingml/2006/main" xmlns:r="http://schemas.openxmlformats.org/officeDocument/2006/relationships" xmlns:p1510="http://schemas.microsoft.com/office/powerpoint/2015/10/main">
+  <p1510:revLst>
+    <p1510:client id="{E6A9D20A-C011-4E55-BE77-B4602C89A585}" v="2" dt="2026-01-22T12:12:04.123"/>
+  </p1510:revLst>
+</p1510:revInfo>
+</file>
+
+<file path=ppt/changesInfos/changesInfo1.xml><?xml version="1.0" encoding="utf-8"?>
+<pc:chgInfo xmlns:a="http://schemas.openxmlformats.org/drawingml/2006/main" xmlns:r="http://schemas.openxmlformats.org/officeDocument/2006/relationships" xmlns:ac="http://schemas.microsoft.com/office/drawing/2013/main/command" xmlns:pc="http://schemas.microsoft.com/office/powerpoint/2013/main/command">
+  <pc:docChgLst>
+    <pc:chgData name="Fatima Pillosu" userId="a6295d4dc9e22643" providerId="LiveId" clId="{87453732-75AC-4426-B5D3-B7C69C2D4F54}"/>
+    <pc:docChg chg="undo custSel modSld">
+      <pc:chgData name="Fatima Pillosu" userId="a6295d4dc9e22643" providerId="LiveId" clId="{87453732-75AC-4426-B5D3-B7C69C2D4F54}" dt="2026-01-22T12:13:40.817" v="201" actId="408"/>
+      <pc:docMkLst>
+        <pc:docMk/>
+      </pc:docMkLst>
+      <pc:sldChg chg="addSp modSp mod">
+        <pc:chgData name="Fatima Pillosu" userId="a6295d4dc9e22643" providerId="LiveId" clId="{87453732-75AC-4426-B5D3-B7C69C2D4F54}" dt="2026-01-22T12:13:40.817" v="201" actId="408"/>
+        <pc:sldMkLst>
+          <pc:docMk/>
+          <pc:sldMk cId="1792385995" sldId="256"/>
+        </pc:sldMkLst>
+        <pc:spChg chg="add mod">
+          <ac:chgData name="Fatima Pillosu" userId="a6295d4dc9e22643" providerId="LiveId" clId="{87453732-75AC-4426-B5D3-B7C69C2D4F54}" dt="2026-01-22T12:13:21.664" v="200" actId="1582"/>
+          <ac:spMkLst>
+            <pc:docMk/>
+            <pc:sldMk cId="1792385995" sldId="256"/>
+            <ac:spMk id="2" creationId="{6475B653-DA3F-5CA6-A884-8D9DA7B69587}"/>
+          </ac:spMkLst>
+        </pc:spChg>
+        <pc:spChg chg="add mod">
+          <ac:chgData name="Fatima Pillosu" userId="a6295d4dc9e22643" providerId="LiveId" clId="{87453732-75AC-4426-B5D3-B7C69C2D4F54}" dt="2026-01-22T12:12:25.184" v="192" actId="1076"/>
+          <ac:spMkLst>
+            <pc:docMk/>
+            <pc:sldMk cId="1792385995" sldId="256"/>
+            <ac:spMk id="3" creationId="{09C68351-2A61-BBB7-2367-244CD19CFD46}"/>
+          </ac:spMkLst>
+        </pc:spChg>
+        <pc:spChg chg="mod">
+          <ac:chgData name="Fatima Pillosu" userId="a6295d4dc9e22643" providerId="LiveId" clId="{87453732-75AC-4426-B5D3-B7C69C2D4F54}" dt="2026-01-22T12:06:13.867" v="42" actId="20577"/>
+          <ac:spMkLst>
+            <pc:docMk/>
+            <pc:sldMk cId="1792385995" sldId="256"/>
+            <ac:spMk id="89" creationId="{90F7001D-92F6-7150-5535-6FD7A71A1F8A}"/>
+          </ac:spMkLst>
+        </pc:spChg>
+        <pc:spChg chg="mod">
+          <ac:chgData name="Fatima Pillosu" userId="a6295d4dc9e22643" providerId="LiveId" clId="{87453732-75AC-4426-B5D3-B7C69C2D4F54}" dt="2026-01-22T12:05:59.308" v="38" actId="255"/>
+          <ac:spMkLst>
+            <pc:docMk/>
+            <pc:sldMk cId="1792385995" sldId="256"/>
+            <ac:spMk id="92" creationId="{52FAA06D-DDE9-2ADD-747D-C3C50786AE5C}"/>
+          </ac:spMkLst>
+        </pc:spChg>
+        <pc:spChg chg="mod">
+          <ac:chgData name="Fatima Pillosu" userId="a6295d4dc9e22643" providerId="LiveId" clId="{87453732-75AC-4426-B5D3-B7C69C2D4F54}" dt="2026-01-22T12:11:17.698" v="170" actId="1037"/>
+          <ac:spMkLst>
+            <pc:docMk/>
+            <pc:sldMk cId="1792385995" sldId="256"/>
+            <ac:spMk id="97" creationId="{58424FDA-F2C3-DE63-F21C-6772F8B5B8F6}"/>
+          </ac:spMkLst>
+        </pc:spChg>
+        <pc:spChg chg="mod">
+          <ac:chgData name="Fatima Pillosu" userId="a6295d4dc9e22643" providerId="LiveId" clId="{87453732-75AC-4426-B5D3-B7C69C2D4F54}" dt="2026-01-22T12:11:28.602" v="179" actId="1038"/>
+          <ac:spMkLst>
+            <pc:docMk/>
+            <pc:sldMk cId="1792385995" sldId="256"/>
+            <ac:spMk id="98" creationId="{17B54E3B-E7AB-A677-EEA0-DB017D160EC5}"/>
+          </ac:spMkLst>
+        </pc:spChg>
+        <pc:spChg chg="mod">
+          <ac:chgData name="Fatima Pillosu" userId="a6295d4dc9e22643" providerId="LiveId" clId="{87453732-75AC-4426-B5D3-B7C69C2D4F54}" dt="2026-01-22T12:06:19.551" v="46" actId="20577"/>
+          <ac:spMkLst>
+            <pc:docMk/>
+            <pc:sldMk cId="1792385995" sldId="256"/>
+            <ac:spMk id="99" creationId="{33D9ADA3-A60D-E106-EE13-5467D5692F2F}"/>
+          </ac:spMkLst>
+        </pc:spChg>
+        <pc:spChg chg="mod">
+          <ac:chgData name="Fatima Pillosu" userId="a6295d4dc9e22643" providerId="LiveId" clId="{87453732-75AC-4426-B5D3-B7C69C2D4F54}" dt="2026-01-22T12:13:40.817" v="201" actId="408"/>
+          <ac:spMkLst>
+            <pc:docMk/>
+            <pc:sldMk cId="1792385995" sldId="256"/>
+            <ac:spMk id="100" creationId="{26D8D8F3-3619-BEB6-47D9-A78EC9897308}"/>
+          </ac:spMkLst>
+        </pc:spChg>
+        <pc:spChg chg="mod">
+          <ac:chgData name="Fatima Pillosu" userId="a6295d4dc9e22643" providerId="LiveId" clId="{87453732-75AC-4426-B5D3-B7C69C2D4F54}" dt="2026-01-22T12:11:17.698" v="170" actId="1037"/>
+          <ac:spMkLst>
+            <pc:docMk/>
+            <pc:sldMk cId="1792385995" sldId="256"/>
+            <ac:spMk id="104" creationId="{186B2EB7-D95B-7FBE-8B82-B63C263B90EB}"/>
+          </ac:spMkLst>
+        </pc:spChg>
+        <pc:spChg chg="mod">
+          <ac:chgData name="Fatima Pillosu" userId="a6295d4dc9e22643" providerId="LiveId" clId="{87453732-75AC-4426-B5D3-B7C69C2D4F54}" dt="2026-01-22T12:11:28.602" v="179" actId="1038"/>
+          <ac:spMkLst>
+            <pc:docMk/>
+            <pc:sldMk cId="1792385995" sldId="256"/>
+            <ac:spMk id="105" creationId="{5E62392E-CD69-DD91-20F9-46EE5C2E15DD}"/>
+          </ac:spMkLst>
+        </pc:spChg>
+        <pc:picChg chg="mod">
+          <ac:chgData name="Fatima Pillosu" userId="a6295d4dc9e22643" providerId="LiveId" clId="{87453732-75AC-4426-B5D3-B7C69C2D4F54}" dt="2026-01-22T12:09:40.234" v="58" actId="1076"/>
+          <ac:picMkLst>
+            <pc:docMk/>
+            <pc:sldMk cId="1792385995" sldId="256"/>
+            <ac:picMk id="101" creationId="{2F7AE519-2885-2AE0-032C-CD88933B29C1}"/>
+          </ac:picMkLst>
+        </pc:picChg>
+        <pc:cxnChg chg="add mod">
+          <ac:chgData name="Fatima Pillosu" userId="a6295d4dc9e22643" providerId="LiveId" clId="{87453732-75AC-4426-B5D3-B7C69C2D4F54}" dt="2026-01-22T12:12:54.057" v="199" actId="1076"/>
+          <ac:cxnSpMkLst>
+            <pc:docMk/>
+            <pc:sldMk cId="1792385995" sldId="256"/>
+            <ac:cxnSpMk id="4" creationId="{7442856A-86B3-26DD-9F34-BB3AF79B144F}"/>
+          </ac:cxnSpMkLst>
+        </pc:cxnChg>
+        <pc:cxnChg chg="mod">
+          <ac:chgData name="Fatima Pillosu" userId="a6295d4dc9e22643" providerId="LiveId" clId="{87453732-75AC-4426-B5D3-B7C69C2D4F54}" dt="2026-01-22T12:11:56.133" v="184" actId="208"/>
+          <ac:cxnSpMkLst>
+            <pc:docMk/>
+            <pc:sldMk cId="1792385995" sldId="256"/>
+            <ac:cxnSpMk id="102" creationId="{47ABC4DD-2A8C-488F-1B5F-46EB12ECAFC1}"/>
+          </ac:cxnSpMkLst>
+        </pc:cxnChg>
+        <pc:cxnChg chg="mod">
+          <ac:chgData name="Fatima Pillosu" userId="a6295d4dc9e22643" providerId="LiveId" clId="{87453732-75AC-4426-B5D3-B7C69C2D4F54}" dt="2026-01-22T12:12:06.825" v="188" actId="208"/>
+          <ac:cxnSpMkLst>
+            <pc:docMk/>
+            <pc:sldMk cId="1792385995" sldId="256"/>
+            <ac:cxnSpMk id="103" creationId="{D32BA22B-09F7-81CF-C7D2-96180B319A88}"/>
+          </ac:cxnSpMkLst>
+        </pc:cxnChg>
+      </pc:sldChg>
+    </pc:docChg>
+  </pc:docChgLst>
+</pc:chgInfo>
 </file>
 
 <file path=ppt/slideLayouts/slideLayout1.xml><?xml version="1.0" encoding="utf-8"?>
@@ -238,7 +384,7 @@
           <a:p>
             <a:fld id="{3FDE4C57-8B7F-40F7-BEC2-4789A4EC913E}" type="datetimeFigureOut">
               <a:rPr lang="it-IT" smtClean="0"/>
-              <a:t>21/01/2026</a:t>
+              <a:t>22/01/2026</a:t>
             </a:fld>
             <a:endParaRPr lang="it-IT"/>
           </a:p>
@@ -408,7 +554,7 @@
           <a:p>
             <a:fld id="{3FDE4C57-8B7F-40F7-BEC2-4789A4EC913E}" type="datetimeFigureOut">
               <a:rPr lang="it-IT" smtClean="0"/>
-              <a:t>21/01/2026</a:t>
+              <a:t>22/01/2026</a:t>
             </a:fld>
             <a:endParaRPr lang="it-IT"/>
           </a:p>
@@ -588,7 +734,7 @@
           <a:p>
             <a:fld id="{3FDE4C57-8B7F-40F7-BEC2-4789A4EC913E}" type="datetimeFigureOut">
               <a:rPr lang="it-IT" smtClean="0"/>
-              <a:t>21/01/2026</a:t>
+              <a:t>22/01/2026</a:t>
             </a:fld>
             <a:endParaRPr lang="it-IT"/>
           </a:p>
@@ -758,7 +904,7 @@
           <a:p>
             <a:fld id="{3FDE4C57-8B7F-40F7-BEC2-4789A4EC913E}" type="datetimeFigureOut">
               <a:rPr lang="it-IT" smtClean="0"/>
-              <a:t>21/01/2026</a:t>
+              <a:t>22/01/2026</a:t>
             </a:fld>
             <a:endParaRPr lang="it-IT"/>
           </a:p>
@@ -1004,7 +1150,7 @@
           <a:p>
             <a:fld id="{3FDE4C57-8B7F-40F7-BEC2-4789A4EC913E}" type="datetimeFigureOut">
               <a:rPr lang="it-IT" smtClean="0"/>
-              <a:t>21/01/2026</a:t>
+              <a:t>22/01/2026</a:t>
             </a:fld>
             <a:endParaRPr lang="it-IT"/>
           </a:p>
@@ -1236,7 +1382,7 @@
           <a:p>
             <a:fld id="{3FDE4C57-8B7F-40F7-BEC2-4789A4EC913E}" type="datetimeFigureOut">
               <a:rPr lang="it-IT" smtClean="0"/>
-              <a:t>21/01/2026</a:t>
+              <a:t>22/01/2026</a:t>
             </a:fld>
             <a:endParaRPr lang="it-IT"/>
           </a:p>
@@ -1603,7 +1749,7 @@
           <a:p>
             <a:fld id="{3FDE4C57-8B7F-40F7-BEC2-4789A4EC913E}" type="datetimeFigureOut">
               <a:rPr lang="it-IT" smtClean="0"/>
-              <a:t>21/01/2026</a:t>
+              <a:t>22/01/2026</a:t>
             </a:fld>
             <a:endParaRPr lang="it-IT"/>
           </a:p>
@@ -1721,7 +1867,7 @@
           <a:p>
             <a:fld id="{3FDE4C57-8B7F-40F7-BEC2-4789A4EC913E}" type="datetimeFigureOut">
               <a:rPr lang="it-IT" smtClean="0"/>
-              <a:t>21/01/2026</a:t>
+              <a:t>22/01/2026</a:t>
             </a:fld>
             <a:endParaRPr lang="it-IT"/>
           </a:p>
@@ -1816,7 +1962,7 @@
           <a:p>
             <a:fld id="{3FDE4C57-8B7F-40F7-BEC2-4789A4EC913E}" type="datetimeFigureOut">
               <a:rPr lang="it-IT" smtClean="0"/>
-              <a:t>21/01/2026</a:t>
+              <a:t>22/01/2026</a:t>
             </a:fld>
             <a:endParaRPr lang="it-IT"/>
           </a:p>
@@ -2093,7 +2239,7 @@
           <a:p>
             <a:fld id="{3FDE4C57-8B7F-40F7-BEC2-4789A4EC913E}" type="datetimeFigureOut">
               <a:rPr lang="it-IT" smtClean="0"/>
-              <a:t>21/01/2026</a:t>
+              <a:t>22/01/2026</a:t>
             </a:fld>
             <a:endParaRPr lang="it-IT"/>
           </a:p>
@@ -2350,7 +2496,7 @@
           <a:p>
             <a:fld id="{3FDE4C57-8B7F-40F7-BEC2-4789A4EC913E}" type="datetimeFigureOut">
               <a:rPr lang="it-IT" smtClean="0"/>
-              <a:t>21/01/2026</a:t>
+              <a:t>22/01/2026</a:t>
             </a:fld>
             <a:endParaRPr lang="it-IT"/>
           </a:p>
@@ -2563,7 +2709,7 @@
           <a:p>
             <a:fld id="{3FDE4C57-8B7F-40F7-BEC2-4789A4EC913E}" type="datetimeFigureOut">
               <a:rPr lang="it-IT" smtClean="0"/>
-              <a:t>21/01/2026</a:t>
+              <a:t>22/01/2026</a:t>
             </a:fld>
             <a:endParaRPr lang="it-IT"/>
           </a:p>
@@ -7265,7 +7411,7 @@
         <p:spPr>
           <a:xfrm>
             <a:off x="135508" y="393237"/>
-            <a:ext cx="1130402" cy="374571"/>
+            <a:ext cx="1130402" cy="510778"/>
           </a:xfrm>
           <a:prstGeom prst="roundRect">
             <a:avLst/>
@@ -7280,6 +7426,22 @@
             <a:spAutoFit/>
           </a:bodyPr>
           <a:lstStyle/>
+          <a:p>
+            <a:pPr algn="ctr"/>
+            <a:r>
+              <a:rPr lang="en-US" sz="800" dirty="0">
+                <a:solidFill>
+                  <a:schemeClr val="tx1">
+                    <a:lumMod val="75000"/>
+                    <a:lumOff val="25000"/>
+                  </a:schemeClr>
+                </a:solidFill>
+                <a:latin typeface="Calibri Light" panose="020F0302020204030204" pitchFamily="34" charset="0"/>
+                <a:cs typeface="Calibri Light" panose="020F0302020204030204" pitchFamily="34" charset="0"/>
+              </a:rPr>
+              <a:t>(a)</a:t>
+            </a:r>
+          </a:p>
           <a:p>
             <a:pPr algn="ctr"/>
             <a:r>
@@ -7397,7 +7559,7 @@
         <p:spPr>
           <a:xfrm>
             <a:off x="167277" y="908192"/>
-            <a:ext cx="1066865" cy="1055608"/>
+            <a:ext cx="1066865" cy="1170980"/>
           </a:xfrm>
           <a:prstGeom prst="roundRect">
             <a:avLst/>
@@ -7432,7 +7594,20 @@
           </a:p>
           <a:p>
             <a:pPr algn="ctr"/>
-            <a:endParaRPr lang="en-US" sz="800" dirty="0">
+            <a:r>
+              <a:rPr lang="en-US" sz="800" dirty="0">
+                <a:solidFill>
+                  <a:srgbClr val="009999"/>
+                </a:solidFill>
+                <a:latin typeface="Calibri Light" panose="020F0302020204030204" pitchFamily="34" charset="0"/>
+                <a:cs typeface="Calibri Light" panose="020F0302020204030204" pitchFamily="34" charset="0"/>
+              </a:rPr>
+              <a:t>(from rain gauges or rada-derived)</a:t>
+            </a:r>
+          </a:p>
+          <a:p>
+            <a:pPr algn="ctr"/>
+            <a:endParaRPr lang="en-US" sz="400" dirty="0">
               <a:solidFill>
                 <a:srgbClr val="009999"/>
               </a:solidFill>
@@ -7458,7 +7633,7 @@
           </a:p>
           <a:p>
             <a:pPr algn="ctr"/>
-            <a:endParaRPr lang="en-US" sz="800" dirty="0">
+            <a:endParaRPr lang="en-US" sz="400" dirty="0">
               <a:solidFill>
                 <a:srgbClr val="009999"/>
               </a:solidFill>
@@ -7687,7 +7862,7 @@
         </p:nvSpPr>
         <p:spPr>
           <a:xfrm>
-            <a:off x="1949448" y="2678036"/>
+            <a:off x="2093284" y="2678036"/>
             <a:ext cx="1176943" cy="461665"/>
           </a:xfrm>
           <a:prstGeom prst="rect">
@@ -7745,7 +7920,7 @@
         </p:nvSpPr>
         <p:spPr>
           <a:xfrm>
-            <a:off x="3044281" y="2668717"/>
+            <a:off x="3090514" y="2668717"/>
             <a:ext cx="1176943" cy="461665"/>
           </a:xfrm>
           <a:prstGeom prst="rect">
@@ -7804,7 +7979,7 @@
         <p:spPr>
           <a:xfrm>
             <a:off x="1721013" y="393237"/>
-            <a:ext cx="2419188" cy="374571"/>
+            <a:ext cx="2419188" cy="510778"/>
           </a:xfrm>
           <a:prstGeom prst="roundRect">
             <a:avLst/>
@@ -7819,6 +7994,22 @@
             <a:spAutoFit/>
           </a:bodyPr>
           <a:lstStyle/>
+          <a:p>
+            <a:pPr algn="ctr"/>
+            <a:r>
+              <a:rPr lang="en-US" sz="800" dirty="0">
+                <a:solidFill>
+                  <a:schemeClr val="tx1">
+                    <a:lumMod val="75000"/>
+                    <a:lumOff val="25000"/>
+                  </a:schemeClr>
+                </a:solidFill>
+                <a:latin typeface="Calibri Light" panose="020F0302020204030204" pitchFamily="34" charset="0"/>
+                <a:cs typeface="Calibri Light" panose="020F0302020204030204" pitchFamily="34" charset="0"/>
+              </a:rPr>
+              <a:t>(b)</a:t>
+            </a:r>
+          </a:p>
           <a:p>
             <a:pPr algn="ctr"/>
             <a:r>
@@ -7867,7 +8058,7 @@
         </p:nvSpPr>
         <p:spPr>
           <a:xfrm>
-            <a:off x="2857946" y="2806395"/>
+            <a:off x="2952980" y="2806395"/>
             <a:ext cx="454781" cy="238363"/>
           </a:xfrm>
           <a:prstGeom prst="roundRect">
@@ -7947,7 +8138,7 @@
         </p:nvCxnSpPr>
         <p:spPr>
           <a:xfrm flipV="1">
-            <a:off x="3632752" y="1541069"/>
+            <a:off x="3678985" y="1541069"/>
             <a:ext cx="0" cy="1126873"/>
           </a:xfrm>
           <a:prstGeom prst="line">
@@ -7955,10 +8146,7 @@
           </a:prstGeom>
           <a:ln w="3175">
             <a:solidFill>
-              <a:schemeClr val="tx1">
-                <a:lumMod val="65000"/>
-                <a:lumOff val="35000"/>
-              </a:schemeClr>
+              <a:srgbClr val="009999"/>
             </a:solidFill>
             <a:headEnd type="triangle" w="sm" len="sm"/>
             <a:tailEnd type="none"/>
@@ -7995,7 +8183,7 @@
         </p:nvCxnSpPr>
         <p:spPr>
           <a:xfrm flipV="1">
-            <a:off x="2537919" y="1541069"/>
+            <a:off x="2681755" y="1541069"/>
             <a:ext cx="0" cy="1126873"/>
           </a:xfrm>
           <a:prstGeom prst="line">
@@ -8003,10 +8191,7 @@
           </a:prstGeom>
           <a:ln w="3175">
             <a:solidFill>
-              <a:schemeClr val="tx1">
-                <a:lumMod val="65000"/>
-                <a:lumOff val="35000"/>
-              </a:schemeClr>
+              <a:srgbClr val="FF0066"/>
             </a:solidFill>
             <a:headEnd type="triangle" w="sm" len="sm"/>
             <a:tailEnd type="none"/>
@@ -8041,7 +8226,7 @@
         </p:nvSpPr>
         <p:spPr>
           <a:xfrm>
-            <a:off x="1951194" y="1202515"/>
+            <a:off x="2095030" y="1202515"/>
             <a:ext cx="1176943" cy="338554"/>
           </a:xfrm>
           <a:prstGeom prst="rect">
@@ -8100,7 +8285,7 @@
                 <a:latin typeface="Calibri Light" panose="020F0302020204030204" pitchFamily="34" charset="0"/>
                 <a:cs typeface="Calibri Light" panose="020F0302020204030204" pitchFamily="34" charset="0"/>
               </a:rPr>
-              <a:t>(e.g., 95</a:t>
+              <a:t>(e.g., 99</a:t>
             </a:r>
             <a:r>
               <a:rPr lang="en-US" sz="800" baseline="30000" dirty="0">
@@ -8139,7 +8324,7 @@
         </p:nvSpPr>
         <p:spPr>
           <a:xfrm>
-            <a:off x="3044281" y="1202515"/>
+            <a:off x="3090514" y="1202515"/>
             <a:ext cx="1176943" cy="338554"/>
           </a:xfrm>
           <a:prstGeom prst="rect">
@@ -8198,7 +8383,7 @@
                 <a:latin typeface="Calibri Light" panose="020F0302020204030204" pitchFamily="34" charset="0"/>
                 <a:cs typeface="Calibri Light" panose="020F0302020204030204" pitchFamily="34" charset="0"/>
               </a:rPr>
-              <a:t>(e.g., 95</a:t>
+              <a:t>(e.g., 99</a:t>
             </a:r>
             <a:r>
               <a:rPr lang="en-US" sz="800" baseline="30000" dirty="0">
@@ -8223,6 +8408,157 @@
           </a:p>
         </p:txBody>
       </p:sp>
+      <p:sp>
+        <p:nvSpPr>
+          <p:cNvPr id="2" name="Left Brace 1">
+            <a:extLst>
+              <a:ext uri="{FF2B5EF4-FFF2-40B4-BE49-F238E27FC236}">
+                <a16:creationId xmlns:a16="http://schemas.microsoft.com/office/drawing/2014/main" id="{6475B653-DA3F-5CA6-A884-8D9DA7B69587}"/>
+              </a:ext>
+            </a:extLst>
+          </p:cNvPr>
+          <p:cNvSpPr/>
+          <p:nvPr/>
+        </p:nvSpPr>
+        <p:spPr>
+          <a:xfrm rot="5400000">
+            <a:off x="3636207" y="2436676"/>
+            <a:ext cx="125966" cy="319477"/>
+          </a:xfrm>
+          <a:prstGeom prst="leftBrace">
+            <a:avLst>
+              <a:gd name="adj1" fmla="val 68169"/>
+              <a:gd name="adj2" fmla="val 50000"/>
+            </a:avLst>
+          </a:prstGeom>
+          <a:ln w="12700">
+            <a:solidFill>
+              <a:schemeClr val="tx1">
+                <a:lumMod val="65000"/>
+                <a:lumOff val="35000"/>
+              </a:schemeClr>
+            </a:solidFill>
+          </a:ln>
+        </p:spPr>
+        <p:style>
+          <a:lnRef idx="2">
+            <a:schemeClr val="accent1"/>
+          </a:lnRef>
+          <a:fillRef idx="0">
+            <a:schemeClr val="accent1"/>
+          </a:fillRef>
+          <a:effectRef idx="1">
+            <a:schemeClr val="accent1"/>
+          </a:effectRef>
+          <a:fontRef idx="minor">
+            <a:schemeClr val="tx1"/>
+          </a:fontRef>
+        </p:style>
+        <p:txBody>
+          <a:bodyPr rtlCol="0" anchor="ctr"/>
+          <a:lstStyle/>
+          <a:p>
+            <a:pPr algn="ctr"/>
+            <a:endParaRPr lang="it-IT"/>
+          </a:p>
+        </p:txBody>
+      </p:sp>
+      <p:sp>
+        <p:nvSpPr>
+          <p:cNvPr id="3" name="TextBox 2">
+            <a:extLst>
+              <a:ext uri="{FF2B5EF4-FFF2-40B4-BE49-F238E27FC236}">
+                <a16:creationId xmlns:a16="http://schemas.microsoft.com/office/drawing/2014/main" id="{09C68351-2A61-BBB7-2367-244CD19CFD46}"/>
+              </a:ext>
+            </a:extLst>
+          </p:cNvPr>
+          <p:cNvSpPr txBox="1"/>
+          <p:nvPr/>
+        </p:nvSpPr>
+        <p:spPr>
+          <a:xfrm>
+            <a:off x="2727497" y="1572884"/>
+            <a:ext cx="899170" cy="646986"/>
+          </a:xfrm>
+          <a:prstGeom prst="roundRect">
+            <a:avLst/>
+          </a:prstGeom>
+          <a:noFill/>
+          <a:ln w="3175">
+            <a:noFill/>
+          </a:ln>
+        </p:spPr>
+        <p:txBody>
+          <a:bodyPr wrap="square" rtlCol="0">
+            <a:spAutoFit/>
+          </a:bodyPr>
+          <a:lstStyle/>
+          <a:p>
+            <a:pPr algn="ctr"/>
+            <a:r>
+              <a:rPr lang="en-US" sz="800" dirty="0">
+                <a:solidFill>
+                  <a:schemeClr val="tx1">
+                    <a:lumMod val="75000"/>
+                    <a:lumOff val="25000"/>
+                  </a:schemeClr>
+                </a:solidFill>
+                <a:latin typeface="Calibri Light" panose="020F0302020204030204" pitchFamily="34" charset="0"/>
+                <a:cs typeface="Calibri Light" panose="020F0302020204030204" pitchFamily="34" charset="0"/>
+              </a:rPr>
+              <a:t>Range of rainfall values that might cause flash floods</a:t>
+            </a:r>
+          </a:p>
+        </p:txBody>
+      </p:sp>
+      <p:cxnSp>
+        <p:nvCxnSpPr>
+          <p:cNvPr id="4" name="Straight Connector 3">
+            <a:extLst>
+              <a:ext uri="{FF2B5EF4-FFF2-40B4-BE49-F238E27FC236}">
+                <a16:creationId xmlns:a16="http://schemas.microsoft.com/office/drawing/2014/main" id="{7442856A-86B3-26DD-9F34-BB3AF79B144F}"/>
+              </a:ext>
+            </a:extLst>
+          </p:cNvPr>
+          <p:cNvCxnSpPr>
+            <a:cxnSpLocks/>
+          </p:cNvCxnSpPr>
+          <p:nvPr/>
+        </p:nvCxnSpPr>
+        <p:spPr>
+          <a:xfrm flipH="1" flipV="1">
+            <a:off x="3332333" y="2263757"/>
+            <a:ext cx="218632" cy="336667"/>
+          </a:xfrm>
+          <a:prstGeom prst="line">
+            <a:avLst/>
+          </a:prstGeom>
+          <a:ln w="3175">
+            <a:solidFill>
+              <a:schemeClr val="tx1">
+                <a:lumMod val="65000"/>
+                <a:lumOff val="35000"/>
+              </a:schemeClr>
+            </a:solidFill>
+            <a:headEnd type="triangle" w="sm" len="sm"/>
+            <a:tailEnd type="none"/>
+          </a:ln>
+        </p:spPr>
+        <p:style>
+          <a:lnRef idx="2">
+            <a:schemeClr val="accent1"/>
+          </a:lnRef>
+          <a:fillRef idx="0">
+            <a:schemeClr val="accent1"/>
+          </a:fillRef>
+          <a:effectRef idx="1">
+            <a:schemeClr val="accent1"/>
+          </a:effectRef>
+          <a:fontRef idx="minor">
+            <a:schemeClr val="tx1"/>
+          </a:fontRef>
+        </p:style>
+      </p:cxnSp>
     </p:spTree>
     <p:extLst>
       <p:ext uri="{BB962C8B-B14F-4D97-AF65-F5344CB8AC3E}">

</xml_diff>

<commit_message>
Improved schematic on VRTs
</commit_message>
<xml_diff>
--- a/chapter_05/figures/schematic_verifying_rainfall_thresholds.pptx
+++ b/chapter_05/figures/schematic_verifying_rainfall_thresholds.pptx
@@ -125,12 +125,12 @@
   <pc:docChgLst>
     <pc:chgData name="Fatima Pillosu" userId="a6295d4dc9e22643" providerId="LiveId" clId="{87453732-75AC-4426-B5D3-B7C69C2D4F54}"/>
     <pc:docChg chg="undo custSel modSld">
-      <pc:chgData name="Fatima Pillosu" userId="a6295d4dc9e22643" providerId="LiveId" clId="{87453732-75AC-4426-B5D3-B7C69C2D4F54}" dt="2026-01-22T12:13:40.817" v="201" actId="408"/>
+      <pc:chgData name="Fatima Pillosu" userId="a6295d4dc9e22643" providerId="LiveId" clId="{87453732-75AC-4426-B5D3-B7C69C2D4F54}" dt="2026-01-22T12:20:56.369" v="216" actId="20577"/>
       <pc:docMkLst>
         <pc:docMk/>
       </pc:docMkLst>
       <pc:sldChg chg="addSp modSp mod">
-        <pc:chgData name="Fatima Pillosu" userId="a6295d4dc9e22643" providerId="LiveId" clId="{87453732-75AC-4426-B5D3-B7C69C2D4F54}" dt="2026-01-22T12:13:40.817" v="201" actId="408"/>
+        <pc:chgData name="Fatima Pillosu" userId="a6295d4dc9e22643" providerId="LiveId" clId="{87453732-75AC-4426-B5D3-B7C69C2D4F54}" dt="2026-01-22T12:20:56.369" v="216" actId="20577"/>
         <pc:sldMkLst>
           <pc:docMk/>
           <pc:sldMk cId="1792385995" sldId="256"/>
@@ -160,6 +160,14 @@
           </ac:spMkLst>
         </pc:spChg>
         <pc:spChg chg="mod">
+          <ac:chgData name="Fatima Pillosu" userId="a6295d4dc9e22643" providerId="LiveId" clId="{87453732-75AC-4426-B5D3-B7C69C2D4F54}" dt="2026-01-22T12:20:56.369" v="216" actId="20577"/>
+          <ac:spMkLst>
+            <pc:docMk/>
+            <pc:sldMk cId="1792385995" sldId="256"/>
+            <ac:spMk id="90" creationId="{3DC3BEB2-454E-19A7-92A3-DDCA65962411}"/>
+          </ac:spMkLst>
+        </pc:spChg>
+        <pc:spChg chg="mod">
           <ac:chgData name="Fatima Pillosu" userId="a6295d4dc9e22643" providerId="LiveId" clId="{87453732-75AC-4426-B5D3-B7C69C2D4F54}" dt="2026-01-22T12:05:59.308" v="38" actId="255"/>
           <ac:spMkLst>
             <pc:docMk/>
@@ -184,7 +192,7 @@
           </ac:spMkLst>
         </pc:spChg>
         <pc:spChg chg="mod">
-          <ac:chgData name="Fatima Pillosu" userId="a6295d4dc9e22643" providerId="LiveId" clId="{87453732-75AC-4426-B5D3-B7C69C2D4F54}" dt="2026-01-22T12:06:19.551" v="46" actId="20577"/>
+          <ac:chgData name="Fatima Pillosu" userId="a6295d4dc9e22643" providerId="LiveId" clId="{87453732-75AC-4426-B5D3-B7C69C2D4F54}" dt="2026-01-22T12:20:49.334" v="210" actId="20577"/>
           <ac:spMkLst>
             <pc:docMk/>
             <pc:sldMk cId="1792385995" sldId="256"/>
@@ -7490,15 +7498,22 @@
           <a:p>
             <a:pPr algn="ctr"/>
             <a:r>
-              <a:rPr lang="en-GB" sz="800" dirty="0">
+              <a:rPr lang="en-GB" sz="800">
                 <a:solidFill>
                   <a:srgbClr val="009999"/>
                 </a:solidFill>
                 <a:latin typeface="Calibri Light" panose="020F0302020204030204" pitchFamily="34" charset="0"/>
                 <a:cs typeface="Calibri Light" panose="020F0302020204030204" pitchFamily="34" charset="0"/>
               </a:rPr>
-              <a:t>POINT SCALE</a:t>
-            </a:r>
+              <a:t>POINT-SCALE</a:t>
+            </a:r>
+            <a:endParaRPr lang="en-GB" sz="800" dirty="0">
+              <a:solidFill>
+                <a:srgbClr val="009999"/>
+              </a:solidFill>
+              <a:latin typeface="Calibri Light" panose="020F0302020204030204" pitchFamily="34" charset="0"/>
+              <a:cs typeface="Calibri Light" panose="020F0302020204030204" pitchFamily="34" charset="0"/>
+            </a:endParaRPr>
           </a:p>
         </p:txBody>
       </p:sp>
@@ -8023,23 +8038,7 @@
                 <a:latin typeface="Calibri Light" panose="020F0302020204030204" pitchFamily="34" charset="0"/>
                 <a:cs typeface="Calibri Light" panose="020F0302020204030204" pitchFamily="34" charset="0"/>
               </a:rPr>
-              <a:t>TYPES OF RAINFALL DISTRIBUTIONS </a:t>
-            </a:r>
-          </a:p>
-          <a:p>
-            <a:pPr algn="ctr"/>
-            <a:r>
-              <a:rPr lang="en-US" sz="800" dirty="0">
-                <a:solidFill>
-                  <a:schemeClr val="tx1">
-                    <a:lumMod val="75000"/>
-                    <a:lumOff val="25000"/>
-                  </a:schemeClr>
-                </a:solidFill>
-                <a:latin typeface="Calibri Light" panose="020F0302020204030204" pitchFamily="34" charset="0"/>
-                <a:cs typeface="Calibri Light" panose="020F0302020204030204" pitchFamily="34" charset="0"/>
-              </a:rPr>
-              <a:t>BASED ON THE RAINFALL ESTIMATES’ RESOLUTION</a:t>
+              <a:t>TYPES OF RAINFALL DISTRIBUTIONS BASED ON THE RAINFALL ESTIMATES’ SPATIAL RESOLUTION</a:t>
             </a:r>
           </a:p>
         </p:txBody>

</xml_diff>